<commit_message>
feat: update presentation content and terminology in Elastic Journey deck
</commit_message>
<xml_diff>
--- a/requisitos/Elastic_Journey_Apresentacao_Executiva_Vivo_V3_Adocao_Corporativa_15min.pptx
+++ b/requisitos/Elastic_Journey_Apresentacao_Executiva_Vivo_V3_Adocao_Corporativa_15min.pptx
@@ -2,17 +2,17 @@
 <file path=ppt/presentation.xml><?xml version="1.0" encoding="utf-8"?>
 <p:presentation xmlns:p="http://schemas.openxmlformats.org/presentationml/2006/main">
   <p:sldMasterIdLst>
-    <p:sldMasterId xmlns:r="http://schemas.openxmlformats.org/officeDocument/2006/relationships" id="2147483648" r:id="Rcb43fab8364c46de"/>
+    <p:sldMasterId xmlns:r="http://schemas.openxmlformats.org/officeDocument/2006/relationships" id="2147483648" r:id="R7d47a7272db54abc"/>
   </p:sldMasterIdLst>
   <p:notesMasterIdLst>
-    <p:notesMasterId xmlns:r="http://schemas.openxmlformats.org/officeDocument/2006/relationships" r:id="Rf3c5188090774d4c"/>
+    <p:notesMasterId xmlns:r="http://schemas.openxmlformats.org/officeDocument/2006/relationships" r:id="Rc5b9376d16444add"/>
   </p:notesMasterIdLst>
   <p:sldIdLst>
-    <p:sldId xmlns:r="http://schemas.openxmlformats.org/officeDocument/2006/relationships" id="256" r:id="R73b310e54d944443"/>
-    <p:sldId xmlns:r="http://schemas.openxmlformats.org/officeDocument/2006/relationships" id="257" r:id="R0cf73962f41c46d7"/>
-    <p:sldId xmlns:r="http://schemas.openxmlformats.org/officeDocument/2006/relationships" id="258" r:id="R198a15df187c41de"/>
-    <p:sldId xmlns:r="http://schemas.openxmlformats.org/officeDocument/2006/relationships" id="259" r:id="Rd6f233afe270410e"/>
-    <p:sldId xmlns:r="http://schemas.openxmlformats.org/officeDocument/2006/relationships" id="260" r:id="R6db3139348dc4e0a"/>
+    <p:sldId xmlns:r="http://schemas.openxmlformats.org/officeDocument/2006/relationships" id="256" r:id="R2d037b6a91bb42b6"/>
+    <p:sldId xmlns:r="http://schemas.openxmlformats.org/officeDocument/2006/relationships" id="257" r:id="Refa36faf33204536"/>
+    <p:sldId xmlns:r="http://schemas.openxmlformats.org/officeDocument/2006/relationships" id="258" r:id="R27b37215a5cc4ed4"/>
+    <p:sldId xmlns:r="http://schemas.openxmlformats.org/officeDocument/2006/relationships" id="259" r:id="R6a05efb1b0ee49a9"/>
+    <p:sldId xmlns:r="http://schemas.openxmlformats.org/officeDocument/2006/relationships" id="260" r:id="R974bfeec251c491c"/>
   </p:sldIdLst>
   <p:sldSz cx="12192000" cy="6858000"/>
   <p:notesSz cx="6858000" cy="9144000"/>
@@ -939,7 +939,7 @@
   </p:cSld>
   <p:clrMap bg1="lt1" tx1="dk1" bg2="lt2" tx2="dk2" accent1="accent1" accent2="accent2" accent3="accent3" accent4="accent4" accent5="accent5" accent6="accent6" hlink="hlink" folHlink="folHlink"/>
   <p:sldLayoutIdLst>
-    <p:sldLayoutId xmlns:r="http://schemas.openxmlformats.org/officeDocument/2006/relationships" id="2147483649" r:id="Rfdb33d6990be466c"/>
+    <p:sldLayoutId xmlns:r="http://schemas.openxmlformats.org/officeDocument/2006/relationships" id="2147483649" r:id="R2ed585853c1842e7"/>
   </p:sldLayoutIdLst>
   <p:txStyles>
     <p:titleStyle>
@@ -1591,7 +1591,7 @@
           <p:nvPr/>
         </p:nvPicPr>
         <p:blipFill>
-          <a:blip xmlns:r="http://schemas.openxmlformats.org/officeDocument/2006/relationships" xmlns:a="http://schemas.openxmlformats.org/drawingml/2006/main" r:embed="R5acd6eeafd54487e"/>
+          <a:blip xmlns:r="http://schemas.openxmlformats.org/officeDocument/2006/relationships" xmlns:a="http://schemas.openxmlformats.org/drawingml/2006/main" r:embed="R339481401c044b36"/>
           <a:srcRect xmlns:a="http://schemas.openxmlformats.org/drawingml/2006/main" l="0" t="27" r="0" b="27"/>
           <a:stretch xmlns:a="http://schemas.openxmlformats.org/drawingml/2006/main">
             <a:fillRect l="0" t="0" r="0" b="0"/>
@@ -1664,10 +1664,10 @@
           <p:nvPr/>
         </p:nvPicPr>
         <p:blipFill>
-          <a:blip xmlns:r="http://schemas.openxmlformats.org/officeDocument/2006/relationships" xmlns:a="http://schemas.openxmlformats.org/drawingml/2006/main" r:embed="R5acd6eeafd54487e">
+          <a:blip xmlns:r="http://schemas.openxmlformats.org/officeDocument/2006/relationships" xmlns:a="http://schemas.openxmlformats.org/drawingml/2006/main" r:embed="R339481401c044b36">
             <a:extLst>
               <a:ext uri="{96DAC541-7B7A-43D3-8B79-37D633B846F1}">
-                <asvg:svgBlip xmlns:asvg="http://schemas.microsoft.com/office/drawing/2016/SVG/main" r:embed="Rfcc4865c723a44e3"/>
+                <asvg:svgBlip xmlns:asvg="http://schemas.microsoft.com/office/drawing/2016/SVG/main" r:embed="Rb02448bf45dc4fbd"/>
               </a:ext>
             </a:extLst>
           </a:blip>
@@ -2139,10 +2139,10 @@
           <p:nvPr/>
         </p:nvPicPr>
         <p:blipFill>
-          <a:blip xmlns:r="http://schemas.openxmlformats.org/officeDocument/2006/relationships" xmlns:a="http://schemas.openxmlformats.org/drawingml/2006/main" r:embed="R9cf3ecb1dd544f3e">
+          <a:blip xmlns:r="http://schemas.openxmlformats.org/officeDocument/2006/relationships" xmlns:a="http://schemas.openxmlformats.org/drawingml/2006/main" r:embed="R026546d5876a4e9e">
             <a:extLst>
               <a:ext uri="{96DAC541-7B7A-43D3-8B79-37D633B846F1}">
-                <asvg:svgBlip xmlns:asvg="http://schemas.microsoft.com/office/drawing/2016/SVG/main" r:embed="R49a66fc8d039413c"/>
+                <asvg:svgBlip xmlns:asvg="http://schemas.microsoft.com/office/drawing/2016/SVG/main" r:embed="R50db6e367bbd403e"/>
               </a:ext>
             </a:extLst>
           </a:blip>
@@ -6054,10 +6054,10 @@
           <p:nvPr/>
         </p:nvPicPr>
         <p:blipFill>
-          <a:blip xmlns:r="http://schemas.openxmlformats.org/officeDocument/2006/relationships" xmlns:a="http://schemas.openxmlformats.org/drawingml/2006/main" r:embed="Ra9843df9d71342d8">
+          <a:blip xmlns:r="http://schemas.openxmlformats.org/officeDocument/2006/relationships" xmlns:a="http://schemas.openxmlformats.org/drawingml/2006/main" r:embed="R469f412158214ee4">
             <a:extLst>
               <a:ext uri="{96DAC541-7B7A-43D3-8B79-37D633B846F1}">
-                <asvg:svgBlip xmlns:asvg="http://schemas.microsoft.com/office/drawing/2016/SVG/main" r:embed="R718bf25ac8dc4c30"/>
+                <asvg:svgBlip xmlns:asvg="http://schemas.microsoft.com/office/drawing/2016/SVG/main" r:embed="R13681c583a884b98"/>
               </a:ext>
             </a:extLst>
           </a:blip>
@@ -6741,7 +6741,7 @@
         </p:spPr>
         <p:txBody>
           <a:bodyPr xmlns:a="http://schemas.openxmlformats.org/drawingml/2006/main" wrap="square" lIns="0" tIns="0" rIns="0" bIns="0" anchor="t">
-            <a:normAutofit fontScale="73752"/>
+            <a:normAutofit fontScale="100000"/>
           </a:bodyPr>
           <a:lstStyle xmlns:a="http://schemas.openxmlformats.org/drawingml/2006/main"/>
           <a:p xmlns:a="http://schemas.openxmlformats.org/drawingml/2006/main">
@@ -6765,7 +6765,7 @@
                 <a:ea typeface="Arial"/>
                 <a:cs typeface="Arial"/>
               </a:rPr>
-              <a:t>Reaproveitar componentes</a:t>
+              <a:t>Reusar</a:t>
             </a:r>
           </a:p>
         </p:txBody>
@@ -7157,7 +7157,7 @@
         </p:spPr>
         <p:txBody>
           <a:bodyPr xmlns:a="http://schemas.openxmlformats.org/drawingml/2006/main" wrap="square" lIns="0" tIns="0" rIns="0" bIns="0" anchor="t">
-            <a:normAutofit fontScale="99542"/>
+            <a:normAutofit fontScale="100000"/>
           </a:bodyPr>
           <a:lstStyle xmlns:a="http://schemas.openxmlformats.org/drawingml/2006/main"/>
           <a:p xmlns:a="http://schemas.openxmlformats.org/drawingml/2006/main">
@@ -7181,7 +7181,7 @@
                 <a:ea typeface="Arial"/>
                 <a:cs typeface="Arial"/>
               </a:rPr>
-              <a:t>Mudar com controle</a:t>
+              <a:t>Mudar uma vez</a:t>
             </a:r>
           </a:p>
         </p:txBody>
@@ -7365,7 +7365,7 @@
         </p:spPr>
         <p:txBody>
           <a:bodyPr xmlns:a="http://schemas.openxmlformats.org/drawingml/2006/main" wrap="square" lIns="0" tIns="0" rIns="0" bIns="0" anchor="t">
-            <a:normAutofit fontScale="72622"/>
+            <a:normAutofit fontScale="100000"/>
           </a:bodyPr>
           <a:lstStyle xmlns:a="http://schemas.openxmlformats.org/drawingml/2006/main"/>
           <a:p xmlns:a="http://schemas.openxmlformats.org/drawingml/2006/main">
@@ -7389,7 +7389,7 @@
                 <a:ea typeface="Arial"/>
                 <a:cs typeface="Arial"/>
               </a:rPr>
-              <a:t>Escalar com previsibilidade</a:t>
+              <a:t>Escalar</a:t>
             </a:r>
           </a:p>
         </p:txBody>
@@ -8741,10 +8741,10 @@
           <p:nvPr/>
         </p:nvPicPr>
         <p:blipFill>
-          <a:blip xmlns:r="http://schemas.openxmlformats.org/officeDocument/2006/relationships" xmlns:a="http://schemas.openxmlformats.org/drawingml/2006/main" r:embed="Rc94a1430036340ce">
+          <a:blip xmlns:r="http://schemas.openxmlformats.org/officeDocument/2006/relationships" xmlns:a="http://schemas.openxmlformats.org/drawingml/2006/main" r:embed="R22a075b3620f4df7">
             <a:extLst>
               <a:ext uri="{96DAC541-7B7A-43D3-8B79-37D633B846F1}">
-                <asvg:svgBlip xmlns:asvg="http://schemas.microsoft.com/office/drawing/2016/SVG/main" r:embed="Rbd173eeaf8c14aaf"/>
+                <asvg:svgBlip xmlns:asvg="http://schemas.microsoft.com/office/drawing/2016/SVG/main" r:embed="R1559e0ac32094f31"/>
               </a:ext>
             </a:extLst>
           </a:blip>
@@ -9042,7 +9042,7 @@
         </p:xfrm>
         <a:graphic xmlns:a="http://schemas.openxmlformats.org/drawingml/2006/main">
           <a:graphicData uri="http://schemas.openxmlformats.org/drawingml/2006/chart">
-            <c:chart xmlns:r="http://schemas.openxmlformats.org/officeDocument/2006/relationships" xmlns:c="http://schemas.openxmlformats.org/drawingml/2006/chart" r:id="Rd377486accef4af6"/>
+            <c:chart xmlns:r="http://schemas.openxmlformats.org/officeDocument/2006/relationships" xmlns:c="http://schemas.openxmlformats.org/drawingml/2006/chart" r:id="R4f5d629b4ebc4f2d"/>
           </a:graphicData>
         </a:graphic>
       </p:graphicFrame>
@@ -10376,10 +10376,10 @@
           <p:nvPr/>
         </p:nvPicPr>
         <p:blipFill>
-          <a:blip xmlns:r="http://schemas.openxmlformats.org/officeDocument/2006/relationships" xmlns:a="http://schemas.openxmlformats.org/drawingml/2006/main" r:embed="R5222a7be2b49494c">
+          <a:blip xmlns:r="http://schemas.openxmlformats.org/officeDocument/2006/relationships" xmlns:a="http://schemas.openxmlformats.org/drawingml/2006/main" r:embed="Ree0e7cee904f4a55">
             <a:extLst>
               <a:ext uri="{96DAC541-7B7A-43D3-8B79-37D633B846F1}">
-                <asvg:svgBlip xmlns:asvg="http://schemas.microsoft.com/office/drawing/2016/SVG/main" r:embed="R22e8a8b111a74d2f"/>
+                <asvg:svgBlip xmlns:asvg="http://schemas.microsoft.com/office/drawing/2016/SVG/main" r:embed="R78b7c77ce16f466f"/>
               </a:ext>
             </a:extLst>
           </a:blip>

</xml_diff>